<commit_message>
Clean up comments: Remove emojis and AI-style markers, make comments more natural and professional
</commit_message>
<xml_diff>
--- a/Vari Docs/26MPEC004 (VARI).pptx
+++ b/Vari Docs/26MPEC004 (VARI).pptx
@@ -222,7 +222,7 @@
             <a:fld id="{B6F00A39-C010-4ACB-890F-2930E6D939D9}" type="datetimeFigureOut">
               <a:rPr lang="en-IN" smtClean="0"/>
               <a:pPr/>
-              <a:t>17-03-2026</a:t>
+              <a:t>01-05-2026</a:t>
             </a:fld>
             <a:endParaRPr lang="en-IN"/>
           </a:p>
@@ -768,7 +768,7 @@
             <a:fld id="{D41546B2-83A6-4C34-BB78-5EC716AE01F1}" type="datetime1">
               <a:rPr lang="en-IN" smtClean="0"/>
               <a:pPr/>
-              <a:t>17-03-2026</a:t>
+              <a:t>01-05-2026</a:t>
             </a:fld>
             <a:endParaRPr lang="en-IN"/>
           </a:p>
@@ -1164,7 +1164,7 @@
             <a:fld id="{D1325679-683A-4496-BD3F-D2BAD31881CE}" type="datetime1">
               <a:rPr lang="en-IN" smtClean="0"/>
               <a:pPr/>
-              <a:t>17-03-2026</a:t>
+              <a:t>01-05-2026</a:t>
             </a:fld>
             <a:endParaRPr lang="en-IN"/>
           </a:p>
@@ -1702,7 +1702,7 @@
             <a:fld id="{660B0D89-547F-4572-AB10-57B3DEC6F594}" type="datetime1">
               <a:rPr lang="en-IN" smtClean="0"/>
               <a:pPr/>
-              <a:t>17-03-2026</a:t>
+              <a:t>01-05-2026</a:t>
             </a:fld>
             <a:endParaRPr lang="en-IN"/>
           </a:p>
@@ -1837,7 +1837,7 @@
             <a:fld id="{D316A85D-D7E0-44BA-BBA0-F883A3EA287A}" type="datetime1">
               <a:rPr lang="en-IN" smtClean="0"/>
               <a:pPr/>
-              <a:t>17-03-2026</a:t>
+              <a:t>01-05-2026</a:t>
             </a:fld>
             <a:endParaRPr lang="en-IN"/>
           </a:p>
@@ -2388,7 +2388,7 @@
             <a:fld id="{40FC0B23-2D51-40BA-B23C-2606EBA0FFB2}" type="datetime1">
               <a:rPr lang="en-IN" smtClean="0"/>
               <a:pPr/>
-              <a:t>17-03-2026</a:t>
+              <a:t>01-05-2026</a:t>
             </a:fld>
             <a:endParaRPr lang="en-IN"/>
           </a:p>
@@ -2683,7 +2683,7 @@
             <a:fld id="{F575FD4E-276E-4C0D-A1FA-7C81740113BC}" type="datetime1">
               <a:rPr lang="en-IN" smtClean="0"/>
               <a:pPr/>
-              <a:t>17-03-2026</a:t>
+              <a:t>01-05-2026</a:t>
             </a:fld>
             <a:endParaRPr lang="en-IN"/>
           </a:p>
@@ -3347,7 +3347,7 @@
             <a:fld id="{D016A894-2DC2-494D-914B-34FC20B606ED}" type="datetime1">
               <a:rPr lang="en-IN" smtClean="0"/>
               <a:pPr/>
-              <a:t>17-03-2026</a:t>
+              <a:t>01-05-2026</a:t>
             </a:fld>
             <a:endParaRPr lang="en-IN"/>
           </a:p>
@@ -3786,7 +3786,7 @@
             <a:fld id="{F48B3BAC-683D-4E0B-B89A-3B4B9EAFC0C8}" type="datetime1">
               <a:rPr lang="en-IN" smtClean="0"/>
               <a:pPr/>
-              <a:t>17-03-2026</a:t>
+              <a:t>01-05-2026</a:t>
             </a:fld>
             <a:endParaRPr lang="en-IN"/>
           </a:p>
@@ -4104,7 +4104,7 @@
             <a:fld id="{A0AC7DD3-F863-49AC-B008-E91D604A679A}" type="datetime1">
               <a:rPr lang="en-IN" smtClean="0"/>
               <a:pPr/>
-              <a:t>17-03-2026</a:t>
+              <a:t>01-05-2026</a:t>
             </a:fld>
             <a:endParaRPr lang="en-IN"/>
           </a:p>
@@ -4841,7 +4841,7 @@
             <a:fld id="{4D5016AF-14E0-4929-9413-4A3CDEBDF6CB}" type="datetime1">
               <a:rPr lang="en-IN" smtClean="0"/>
               <a:pPr/>
-              <a:t>17-03-2026</a:t>
+              <a:t>01-05-2026</a:t>
             </a:fld>
             <a:endParaRPr lang="en-IN"/>
           </a:p>
@@ -5509,7 +5509,7 @@
             <a:fld id="{DB4627EF-91FE-47C7-A992-DB68C3759100}" type="datetime1">
               <a:rPr lang="en-IN" smtClean="0"/>
               <a:pPr/>
-              <a:t>17-03-2026</a:t>
+              <a:t>01-05-2026</a:t>
             </a:fld>
             <a:endParaRPr lang="en-IN"/>
           </a:p>
@@ -5786,7 +5786,7 @@
             <a:fld id="{B5D43A2D-C656-4313-9F39-EB6E62B858E1}" type="datetime1">
               <a:rPr lang="en-IN" smtClean="0"/>
               <a:pPr/>
-              <a:t>17-03-2026</a:t>
+              <a:t>01-05-2026</a:t>
             </a:fld>
             <a:endParaRPr lang="en-IN"/>
           </a:p>
@@ -6752,7 +6752,7 @@
           <a:p>
             <a:r>
               <a:rPr lang="en-IN" dirty="0"/>
-              <a:t>17/03/2026</a:t>
+              <a:t>01/05/2026</a:t>
             </a:r>
           </a:p>
           <a:p>
@@ -6777,7 +6777,7 @@
           <a:p>
             <a:r>
               <a:rPr lang="en-IN" dirty="0"/>
-              <a:t>26MPEC003 (VARI)</a:t>
+              <a:t>26MPEC004 (VARI)</a:t>
             </a:r>
           </a:p>
         </p:txBody>
@@ -6936,7 +6936,7 @@
           <a:p>
             <a:r>
               <a:rPr lang="en-IN" dirty="0"/>
-              <a:t>17/03/2026</a:t>
+              <a:t>01/05/2026</a:t>
             </a:r>
           </a:p>
           <a:p>
@@ -6961,7 +6961,7 @@
           <a:p>
             <a:r>
               <a:rPr lang="en-IN" dirty="0"/>
-              <a:t>26MPEC003 (VARI)</a:t>
+              <a:t>26MPEC004 (VARI)</a:t>
             </a:r>
           </a:p>
         </p:txBody>
@@ -7136,7 +7136,7 @@
           <a:p>
             <a:r>
               <a:rPr lang="en-IN" dirty="0"/>
-              <a:t>17/03/2026</a:t>
+              <a:t>01/05/2026</a:t>
             </a:r>
           </a:p>
           <a:p>
@@ -7161,7 +7161,7 @@
           <a:p>
             <a:r>
               <a:rPr lang="en-IN" dirty="0"/>
-              <a:t>26MPEC003 (VARI)</a:t>
+              <a:t>26MPEC004 (VARI)</a:t>
             </a:r>
           </a:p>
         </p:txBody>
@@ -7341,7 +7341,7 @@
           <a:p>
             <a:r>
               <a:rPr lang="en-IN" dirty="0"/>
-              <a:t>17/03/2026</a:t>
+              <a:t>01/05/2026</a:t>
             </a:r>
           </a:p>
           <a:p>
@@ -7366,7 +7366,7 @@
           <a:p>
             <a:r>
               <a:rPr lang="en-IN" dirty="0"/>
-              <a:t>26MPEC003 (VARI)</a:t>
+              <a:t>26MPEC004 (VARI)</a:t>
             </a:r>
           </a:p>
         </p:txBody>
@@ -7436,14 +7436,14 @@
           <p:nvPr>
             <p:extLst>
               <p:ext uri="{D42A27DB-BD31-4B8C-83A1-F6EECF244321}">
-                <p14:modId xmlns:p14="http://schemas.microsoft.com/office/powerpoint/2010/main" val="630894379"/>
+                <p14:modId xmlns:p14="http://schemas.microsoft.com/office/powerpoint/2010/main" val="1136230913"/>
               </p:ext>
             </p:extLst>
           </p:nvPr>
         </p:nvGraphicFramePr>
         <p:xfrm>
           <a:off x="251520" y="1506517"/>
-          <a:ext cx="8640960" cy="4754801"/>
+          <a:ext cx="8640960" cy="4670577"/>
         </p:xfrm>
         <a:graphic>
           <a:graphicData uri="http://schemas.openxmlformats.org/drawingml/2006/table">
@@ -7707,7 +7707,7 @@
                       <a:pPr algn="ctr"/>
                       <a:r>
                         <a:rPr lang="en-US" dirty="0"/>
-                        <a:t>PENDING</a:t>
+                        <a:t>COMPLETED</a:t>
                       </a:r>
                     </a:p>
                   </a:txBody>
@@ -7719,7 +7719,7 @@
                   </a:ext>
                 </a:extLst>
               </a:tr>
-              <a:tr h="659862">
+              <a:tr h="575638">
                 <a:tc>
                   <a:txBody>
                     <a:bodyPr/>
@@ -7756,7 +7756,7 @@
                       <a:pPr algn="ctr"/>
                       <a:r>
                         <a:rPr lang="en-US" dirty="0"/>
-                        <a:t>PENDING</a:t>
+                        <a:t>COMPLETED</a:t>
                       </a:r>
                     </a:p>
                   </a:txBody>
@@ -7791,7 +7791,7 @@
                       <a:pPr algn="ctr"/>
                       <a:r>
                         <a:rPr lang="en-US" dirty="0"/>
-                        <a:t>Offline Mode &amp; Export CSV</a:t>
+                        <a:t>One Time Password for Login</a:t>
                       </a:r>
                     </a:p>
                   </a:txBody>
@@ -7805,7 +7805,7 @@
                       <a:pPr algn="ctr"/>
                       <a:r>
                         <a:rPr lang="en-US" dirty="0"/>
-                        <a:t>PENDING</a:t>
+                        <a:t>COMPLETED</a:t>
                       </a:r>
                     </a:p>
                   </a:txBody>
@@ -7894,7 +7894,7 @@
           <a:p>
             <a:r>
               <a:rPr lang="en-IN" dirty="0"/>
-              <a:t>17/03/2026</a:t>
+              <a:t>01/05/2026</a:t>
             </a:r>
           </a:p>
           <a:p>
@@ -7919,7 +7919,7 @@
           <a:p>
             <a:r>
               <a:rPr lang="en-IN" dirty="0"/>
-              <a:t>26MPEC003 (VARI)</a:t>
+              <a:t>26MPEC004 (VARI)</a:t>
             </a:r>
           </a:p>
         </p:txBody>
@@ -8273,7 +8273,7 @@
           <a:p>
             <a:r>
               <a:rPr lang="en-IN" dirty="0"/>
-              <a:t>17/03/2026</a:t>
+              <a:t>01/05/2026</a:t>
             </a:r>
           </a:p>
         </p:txBody>
@@ -8319,7 +8319,7 @@
           <a:p>
             <a:r>
               <a:rPr lang="en-IN" dirty="0"/>
-              <a:t>26MPEC003 VARI</a:t>
+              <a:t>26MPEC004 VARI</a:t>
             </a:r>
           </a:p>
         </p:txBody>
@@ -8489,7 +8489,7 @@
           <a:p>
             <a:r>
               <a:rPr lang="en-IN" dirty="0"/>
-              <a:t>17/03/2026</a:t>
+              <a:t>01/05/2026</a:t>
             </a:r>
           </a:p>
           <a:p>
@@ -8538,7 +8538,7 @@
           <a:p>
             <a:r>
               <a:rPr lang="en-IN" dirty="0"/>
-              <a:t>26MPEC003 (VARI)</a:t>
+              <a:t>26MPEC004 (VARI)</a:t>
             </a:r>
           </a:p>
         </p:txBody>
@@ -8670,7 +8670,7 @@
           <a:p>
             <a:r>
               <a:rPr lang="en-IN" dirty="0"/>
-              <a:t>17/03/2026</a:t>
+              <a:t>01/05/2026</a:t>
             </a:r>
           </a:p>
           <a:p>
@@ -8719,7 +8719,7 @@
           <a:p>
             <a:r>
               <a:rPr lang="en-IN" dirty="0"/>
-              <a:t>26MPEC003 (VARI)</a:t>
+              <a:t>26MPEC004 (VARI)</a:t>
             </a:r>
           </a:p>
         </p:txBody>
@@ -8924,7 +8924,7 @@
           <a:p>
             <a:r>
               <a:rPr lang="en-IN" dirty="0"/>
-              <a:t>17/03/2026</a:t>
+              <a:t>01/05/2026</a:t>
             </a:r>
           </a:p>
           <a:p>
@@ -8973,7 +8973,7 @@
           <a:p>
             <a:r>
               <a:rPr lang="en-IN" dirty="0"/>
-              <a:t>26MPEC003 (VARI)</a:t>
+              <a:t>26MPEC004 (VARI)</a:t>
             </a:r>
           </a:p>
         </p:txBody>
@@ -9049,7 +9049,7 @@
           <a:p>
             <a:r>
               <a:rPr lang="en-IN" dirty="0"/>
-              <a:t>17/03/2026</a:t>
+              <a:t>01/05/2026</a:t>
             </a:r>
           </a:p>
           <a:p>
@@ -9074,7 +9074,7 @@
           <a:p>
             <a:r>
               <a:rPr lang="en-IN" dirty="0"/>
-              <a:t>26MPEC003 (VARI)</a:t>
+              <a:t>26MPEC004 (VARI)</a:t>
             </a:r>
           </a:p>
         </p:txBody>
@@ -9532,7 +9532,7 @@
           <a:p>
             <a:r>
               <a:rPr lang="en-IN" dirty="0"/>
-              <a:t>17/03/2026</a:t>
+              <a:t>01/05/2026</a:t>
             </a:r>
           </a:p>
           <a:p>
@@ -9557,7 +9557,7 @@
           <a:p>
             <a:r>
               <a:rPr lang="en-IN" dirty="0"/>
-              <a:t>26MPEC003 (VARI)</a:t>
+              <a:t>26MPEC004 (VARI)</a:t>
             </a:r>
           </a:p>
         </p:txBody>
@@ -9790,7 +9790,7 @@
           <a:p>
             <a:r>
               <a:rPr lang="en-IN" dirty="0"/>
-              <a:t>17/03/2026</a:t>
+              <a:t>01/05/2026</a:t>
             </a:r>
           </a:p>
           <a:p>
@@ -9839,7 +9839,7 @@
           <a:p>
             <a:r>
               <a:rPr lang="en-IN" dirty="0"/>
-              <a:t>26MPEC003 (VARI)</a:t>
+              <a:t>26MPEC004 (VARI)</a:t>
             </a:r>
           </a:p>
         </p:txBody>
@@ -9913,7 +9913,7 @@
           <a:p>
             <a:r>
               <a:rPr lang="en-IN" dirty="0"/>
-              <a:t>17/03/2026</a:t>
+              <a:t>01/05/2026</a:t>
             </a:r>
           </a:p>
           <a:p>
@@ -9938,7 +9938,7 @@
           <a:p>
             <a:r>
               <a:rPr lang="en-IN" dirty="0"/>
-              <a:t>26MPEC003 (VARI)</a:t>
+              <a:t>26MPEC004 (VARI)</a:t>
             </a:r>
           </a:p>
         </p:txBody>

</xml_diff>